<commit_message>
Deck edits: resume-based background, reframed problem, simpler eval, SME certification
- Introduction: accurate background from resume (Staff PM, 15+ yrs, applied AI:
  GenAI/LLM orchestration, Agentforce, predictive scoring); removed "new to AI".
- Context & Problem: reframed to "team needs a system to ask product questions";
  scattered/stale product truth as the pain (dropped the live-customer-call framing).
- Evaluation & Results: rewritten in plain language (plain metric table + a clear
  "15/15" validation; hard truths as 3 understandable lessons).
- Retrospective: added SME source certification (experts certify documents before
  they enter the agent) as the lead future item.
- Q&A doc: aligned the background/AI-experience answer to the resume.

Co-Authored-By: Claude Opus 4.8 <noreply@anthropic.com>
</commit_message>
<xml_diff>
--- a/presentation/Executive_Presentation.pptx
+++ b/presentation/Executive_Presentation.pptx
@@ -5073,7 +5073,7 @@
                 </a:solidFill>
                 <a:latin typeface="Arial"/>
               </a:rPr>
-              <a:t>EVALUATION &amp; RESULTS · EVALUATION &amp; SUCCESS</a:t>
+              <a:t>EVALUATION &amp; RESULTS</a:t>
             </a:r>
           </a:p>
         </p:txBody>
@@ -5151,7 +5151,7 @@
                 </a:solidFill>
                 <a:latin typeface="Arial"/>
               </a:rPr>
-              <a:t>Success beyond loss — trust SLOs tied to KPIs</a:t>
+              <a:t>How I measured success</a:t>
             </a:r>
           </a:p>
         </p:txBody>
@@ -5164,7 +5164,7 @@
         </p:nvSpPr>
         <p:spPr>
           <a:xfrm>
-            <a:off x="868680" y="1783080"/>
+            <a:off x="868680" y="1737360"/>
             <a:ext cx="10424160" cy="3931920"/>
           </a:xfrm>
           <a:prstGeom prst="rect">
@@ -5184,7 +5184,7 @@
               </a:spcAft>
             </a:pPr>
             <a:r>
-              <a:rPr sz="1400" b="1" i="0">
+              <a:rPr sz="1500" b="1" i="0">
                 <a:solidFill>
                   <a:srgbClr val="FA582D"/>
                 </a:solidFill>
@@ -5193,31 +5193,13 @@
               <a:t>●  </a:t>
             </a:r>
             <a:r>
-              <a:rPr sz="1400" b="0" i="0">
-                <a:solidFill>
-                  <a:srgbClr val="1A1D24"/>
-                </a:solidFill>
-                <a:latin typeface="Arial"/>
-              </a:rPr>
-              <a:t>No single label to optimize — it's a </a:t>
-            </a:r>
-            <a:r>
-              <a:rPr sz="1400" b="1" i="0">
-                <a:solidFill>
-                  <a:srgbClr val="1A1D24"/>
-                </a:solidFill>
-                <a:latin typeface="Arial"/>
-              </a:rPr>
-              <a:t>trust</a:t>
-            </a:r>
-            <a:r>
-              <a:rPr sz="1400" b="0" i="0">
-                <a:solidFill>
-                  <a:srgbClr val="1A1D24"/>
-                </a:solidFill>
-                <a:latin typeface="Arial"/>
-              </a:rPr>
-              <a:t> product, so success = trust/safety SLOs that map to the business:</a:t>
+              <a:rPr sz="1500" b="0" i="0">
+                <a:solidFill>
+                  <a:srgbClr val="1A1D24"/>
+                </a:solidFill>
+                <a:latin typeface="Arial"/>
+              </a:rPr>
+              <a:t>Not “does it sound smart?” — I set quality bars a salesperson can rely on:</a:t>
             </a:r>
           </a:p>
         </p:txBody>
@@ -5231,8 +5213,8 @@
           <p:nvPr/>
         </p:nvGraphicFramePr>
         <p:xfrm>
-          <a:off x="868680" y="2331720"/>
-          <a:ext cx="10424160" cy="1993391"/>
+          <a:off x="868680" y="2286000"/>
+          <a:ext cx="10424160" cy="1609344"/>
         </p:xfrm>
         <a:graphic>
           <a:graphicData uri="http://schemas.openxmlformats.org/drawingml/2006/table">
@@ -5241,24 +5223,23 @@
                 <a:tableStyleId>{5C22544A-7EE6-4342-B048-85BDC9FD1C3A}</a:tableStyleId>
               </a:tblPr>
               <a:tblGrid>
-                <a:gridCol w="4206240"/>
-                <a:gridCol w="1828800"/>
-                <a:gridCol w="4389120"/>
+                <a:gridCol w="7680960"/>
+                <a:gridCol w="2743200"/>
               </a:tblGrid>
-              <a:tr h="398678">
+              <a:tr h="402336">
                 <a:tc>
                   <a:txBody>
                     <a:bodyPr/>
                     <a:lstStyle/>
                     <a:p>
                       <a:r>
-                        <a:rPr sz="1250" b="1" i="0">
+                        <a:rPr sz="1400" b="1" i="0">
                           <a:solidFill>
                             <a:srgbClr val="FFFFFF"/>
                           </a:solidFill>
                           <a:latin typeface="Arial"/>
                         </a:rPr>
-                        <a:t>KPI</a:t>
+                        <a:t>What I measured</a:t>
                       </a:r>
                     </a:p>
                   </a:txBody>
@@ -5274,7 +5255,7 @@
                     <a:lstStyle/>
                     <a:p>
                       <a:r>
-                        <a:rPr sz="1250" b="1" i="0">
+                        <a:rPr sz="1400" b="1" i="0">
                           <a:solidFill>
                             <a:srgbClr val="FFFFFF"/>
                           </a:solidFill>
@@ -5290,43 +5271,21 @@
                     </a:solidFill>
                   </a:tcPr>
                 </a:tc>
+              </a:tr>
+              <a:tr h="402336">
                 <a:tc>
                   <a:txBody>
                     <a:bodyPr/>
                     <a:lstStyle/>
                     <a:p>
                       <a:r>
-                        <a:rPr sz="1250" b="1" i="0">
-                          <a:solidFill>
-                            <a:srgbClr val="FFFFFF"/>
-                          </a:solidFill>
-                          <a:latin typeface="Arial"/>
-                        </a:rPr>
-                        <a:t>Why it's the business metric</a:t>
-                      </a:r>
-                    </a:p>
-                  </a:txBody>
-                  <a:tcPr>
-                    <a:solidFill>
-                      <a:srgbClr val="1A1D24"/>
-                    </a:solidFill>
-                  </a:tcPr>
-                </a:tc>
-              </a:tr>
-              <a:tr h="398678">
-                <a:tc>
-                  <a:txBody>
-                    <a:bodyPr/>
-                    <a:lstStyle/>
-                    <a:p>
-                      <a:r>
-                        <a:rPr sz="1250" b="0" i="0">
+                        <a:rPr sz="1400" b="0" i="0">
                           <a:solidFill>
                             <a:srgbClr val="E0410F"/>
                           </a:solidFill>
                           <a:latin typeface="Arial"/>
                         </a:rPr>
-                        <a:t>Factual claims with a citation</a:t>
+                        <a:t>Every answer shows its source</a:t>
                       </a:r>
                     </a:p>
                   </a:txBody>
@@ -5342,7 +5301,7 @@
                     <a:lstStyle/>
                     <a:p>
                       <a:r>
-                        <a:rPr sz="1250" b="0" i="0">
+                        <a:rPr sz="1400" b="0" i="0">
                           <a:solidFill>
                             <a:srgbClr val="1A1D24"/>
                           </a:solidFill>
@@ -5358,43 +5317,21 @@
                     </a:solidFill>
                   </a:tcPr>
                 </a:tc>
+              </a:tr>
+              <a:tr h="402336">
                 <a:tc>
                   <a:txBody>
                     <a:bodyPr/>
                     <a:lstStyle/>
                     <a:p>
                       <a:r>
-                        <a:rPr sz="1250" b="0" i="0">
-                          <a:solidFill>
-                            <a:srgbClr val="1A1D24"/>
-                          </a:solidFill>
-                          <a:latin typeface="Arial"/>
-                        </a:rPr>
-                        <a:t>The product promise</a:t>
-                      </a:r>
-                    </a:p>
-                  </a:txBody>
-                  <a:tcPr>
-                    <a:solidFill>
-                      <a:srgbClr val="FFFFFF"/>
-                    </a:solidFill>
-                  </a:tcPr>
-                </a:tc>
-              </a:tr>
-              <a:tr h="398678">
-                <a:tc>
-                  <a:txBody>
-                    <a:bodyPr/>
-                    <a:lstStyle/>
-                    <a:p>
-                      <a:r>
-                        <a:rPr sz="1250" b="0" i="0">
+                        <a:rPr sz="1400" b="0" i="0">
                           <a:solidFill>
                             <a:srgbClr val="E0410F"/>
                           </a:solidFill>
                           <a:latin typeface="Arial"/>
                         </a:rPr>
-                        <a:t>Unsupported-claim / broken-citation</a:t>
+                        <a:t>Answers drawn from outdated / retired documents</a:t>
                       </a:r>
                     </a:p>
                   </a:txBody>
@@ -5410,35 +5347,13 @@
                     <a:lstStyle/>
                     <a:p>
                       <a:r>
-                        <a:rPr sz="1250" b="0" i="0">
+                        <a:rPr sz="1400" b="0" i="0">
                           <a:solidFill>
                             <a:srgbClr val="1A1D24"/>
                           </a:solidFill>
                           <a:latin typeface="Arial"/>
                         </a:rPr>
-                        <a:t>&lt; 2% / &lt; 1%</a:t>
-                      </a:r>
-                    </a:p>
-                  </a:txBody>
-                  <a:tcPr>
-                    <a:solidFill>
-                      <a:srgbClr val="F6F7F9"/>
-                    </a:solidFill>
-                  </a:tcPr>
-                </a:tc>
-                <a:tc>
-                  <a:txBody>
-                    <a:bodyPr/>
-                    <a:lstStyle/>
-                    <a:p>
-                      <a:r>
-                        <a:rPr sz="1250" b="0" i="0">
-                          <a:solidFill>
-                            <a:srgbClr val="1A1D24"/>
-                          </a:solidFill>
-                          <a:latin typeface="Arial"/>
-                        </a:rPr>
-                        <a:t>Hallucination ceiling; dead links kill trust</a:t>
+                        <a:t>0%</a:t>
                       </a:r>
                     </a:p>
                   </a:txBody>
@@ -5449,20 +5364,20 @@
                   </a:tcPr>
                 </a:tc>
               </a:tr>
-              <a:tr h="398678">
+              <a:tr h="402336">
                 <a:tc>
                   <a:txBody>
                     <a:bodyPr/>
                     <a:lstStyle/>
                     <a:p>
                       <a:r>
-                        <a:rPr sz="1250" b="0" i="0">
+                        <a:rPr sz="1400" b="0" i="0">
                           <a:solidFill>
                             <a:srgbClr val="E0410F"/>
                           </a:solidFill>
                           <a:latin typeface="Arial"/>
                         </a:rPr>
-                        <a:t>Deprecated-source usage</a:t>
+                        <a:t>A shaky answer shown as if it were solid</a:t>
                       </a:r>
                     </a:p>
                   </a:txBody>
@@ -5478,35 +5393,13 @@
                     <a:lstStyle/>
                     <a:p>
                       <a:r>
-                        <a:rPr sz="1250" b="0" i="0">
+                        <a:rPr sz="1400" b="0" i="0">
                           <a:solidFill>
                             <a:srgbClr val="1A1D24"/>
                           </a:solidFill>
                           <a:latin typeface="Arial"/>
                         </a:rPr>
-                        <a:t>0%</a:t>
-                      </a:r>
-                    </a:p>
-                  </a:txBody>
-                  <a:tcPr>
-                    <a:solidFill>
-                      <a:srgbClr val="FFFFFF"/>
-                    </a:solidFill>
-                  </a:tcPr>
-                </a:tc>
-                <a:tc>
-                  <a:txBody>
-                    <a:bodyPr/>
-                    <a:lstStyle/>
-                    <a:p>
-                      <a:r>
-                        <a:rPr sz="1250" b="0" i="0">
-                          <a:solidFill>
-                            <a:srgbClr val="1A1D24"/>
-                          </a:solidFill>
-                          <a:latin typeface="Arial"/>
-                        </a:rPr>
-                        <a:t>Wrong-version answers lose deals</a:t>
+                        <a:t>0%  (it asks a human instead)</a:t>
                       </a:r>
                     </a:p>
                   </a:txBody>
@@ -5517,88 +5410,188 @@
                   </a:tcPr>
                 </a:tc>
               </a:tr>
-              <a:tr h="398679">
-                <a:tc>
-                  <a:txBody>
-                    <a:bodyPr/>
-                    <a:lstStyle/>
-                    <a:p>
-                      <a:r>
-                        <a:rPr sz="1250" b="0" i="0">
-                          <a:solidFill>
-                            <a:srgbClr val="E0410F"/>
-                          </a:solidFill>
-                          <a:latin typeface="Arial"/>
-                        </a:rPr>
-                        <a:t>Low-confidence shown without escalation</a:t>
-                      </a:r>
-                    </a:p>
-                  </a:txBody>
-                  <a:tcPr>
-                    <a:solidFill>
-                      <a:srgbClr val="F6F7F9"/>
-                    </a:solidFill>
-                  </a:tcPr>
-                </a:tc>
-                <a:tc>
-                  <a:txBody>
-                    <a:bodyPr/>
-                    <a:lstStyle/>
-                    <a:p>
-                      <a:r>
-                        <a:rPr sz="1250" b="0" i="0">
-                          <a:solidFill>
-                            <a:srgbClr val="1A1D24"/>
-                          </a:solidFill>
-                          <a:latin typeface="Arial"/>
-                        </a:rPr>
-                        <a:t>0%</a:t>
-                      </a:r>
-                    </a:p>
-                  </a:txBody>
-                  <a:tcPr>
-                    <a:solidFill>
-                      <a:srgbClr val="F6F7F9"/>
-                    </a:solidFill>
-                  </a:tcPr>
-                </a:tc>
-                <a:tc>
-                  <a:txBody>
-                    <a:bodyPr/>
-                    <a:lstStyle/>
-                    <a:p>
-                      <a:r>
-                        <a:rPr sz="1250" b="0" i="0">
-                          <a:solidFill>
-                            <a:srgbClr val="1A1D24"/>
-                          </a:solidFill>
-                          <a:latin typeface="Arial"/>
-                        </a:rPr>
-                        <a:t>Know what you don't know</a:t>
-                      </a:r>
-                    </a:p>
-                  </a:txBody>
-                  <a:tcPr>
-                    <a:solidFill>
-                      <a:srgbClr val="F6F7F9"/>
-                    </a:solidFill>
-                  </a:tcPr>
-                </a:tc>
-              </a:tr>
             </a:tbl>
           </a:graphicData>
         </a:graphic>
       </p:graphicFrame>
       <p:sp>
         <p:nvSpPr>
-          <p:cNvPr id="7" name="TextBox 6"/>
+          <p:cNvPr id="7" name="Rounded Rectangle 6"/>
+          <p:cNvSpPr/>
+          <p:nvPr/>
+        </p:nvSpPr>
+        <p:spPr>
+          <a:xfrm>
+            <a:off x="868680" y="4160520"/>
+            <a:ext cx="10424160" cy="1463040"/>
+          </a:xfrm>
+          <a:prstGeom prst="roundRect">
+            <a:avLst/>
+          </a:prstGeom>
+          <a:solidFill>
+            <a:srgbClr val="E7F4EC"/>
+          </a:solidFill>
+          <a:ln w="12700">
+            <a:solidFill>
+              <a:srgbClr val="1E8E3E"/>
+            </a:solidFill>
+          </a:ln>
+          <a:effectLst/>
+        </p:spPr>
+        <p:style>
+          <a:lnRef idx="1">
+            <a:schemeClr val="accent1"/>
+          </a:lnRef>
+          <a:fillRef idx="3">
+            <a:schemeClr val="accent1"/>
+          </a:fillRef>
+          <a:effectRef idx="2">
+            <a:schemeClr val="accent1"/>
+          </a:effectRef>
+          <a:fontRef idx="minor">
+            <a:schemeClr val="lt1"/>
+          </a:fontRef>
+        </p:style>
+        <p:txBody>
+          <a:bodyPr rtlCol="0" anchor="ctr"/>
+          <a:lstStyle/>
+          <a:p>
+            <a:pPr algn="ctr"/>
+          </a:p>
+        </p:txBody>
+      </p:sp>
+      <p:sp>
+        <p:nvSpPr>
+          <p:cNvPr id="8" name="TextBox 7"/>
           <p:cNvSpPr txBox="1"/>
           <p:nvPr/>
         </p:nvSpPr>
         <p:spPr>
           <a:xfrm>
-            <a:off x="868680" y="5257800"/>
-            <a:ext cx="10424160" cy="731520"/>
+            <a:off x="1143000" y="4297680"/>
+            <a:ext cx="9966960" cy="1234440"/>
+          </a:xfrm>
+          <a:prstGeom prst="rect">
+            <a:avLst/>
+          </a:prstGeom>
+          <a:noFill/>
+        </p:spPr>
+        <p:txBody>
+          <a:bodyPr wrap="square" anchor="ctr">
+            <a:spAutoFit/>
+          </a:bodyPr>
+          <a:lstStyle/>
+          <a:p>
+            <a:r>
+              <a:rPr sz="1400" b="1" i="0">
+                <a:solidFill>
+                  <a:srgbClr val="1E8E3E"/>
+                </a:solidFill>
+                <a:latin typeface="Arial"/>
+              </a:rPr>
+              <a:t>How I validated it</a:t>
+            </a:r>
+          </a:p>
+          <a:p>
+            <a:pPr>
+              <a:spcBef>
+                <a:spcPts val="500"/>
+              </a:spcBef>
+            </a:pPr>
+            <a:r>
+              <a:rPr sz="1500" b="0" i="0">
+                <a:solidFill>
+                  <a:srgbClr val="1A1D24"/>
+                </a:solidFill>
+                <a:latin typeface="Arial"/>
+              </a:rPr>
+              <a:t>I tested </a:t>
+            </a:r>
+            <a:r>
+              <a:rPr sz="1500" b="1" i="0">
+                <a:solidFill>
+                  <a:srgbClr val="1A1D24"/>
+                </a:solidFill>
+                <a:latin typeface="Arial"/>
+              </a:rPr>
+              <a:t>15 real questions</a:t>
+            </a:r>
+            <a:r>
+              <a:rPr sz="1500" b="0" i="0">
+                <a:solidFill>
+                  <a:srgbClr val="1A1D24"/>
+                </a:solidFill>
+                <a:latin typeface="Arial"/>
+              </a:rPr>
+              <a:t> — 5 easy, 5 medium, 5 hard. It </a:t>
+            </a:r>
+            <a:r>
+              <a:rPr sz="1500" b="1" i="0">
+                <a:solidFill>
+                  <a:srgbClr val="1A1D24"/>
+                </a:solidFill>
+                <a:latin typeface="Arial"/>
+              </a:rPr>
+              <a:t>answered</a:t>
+            </a:r>
+            <a:r>
+              <a:rPr sz="1500" b="0" i="0">
+                <a:solidFill>
+                  <a:srgbClr val="1A1D24"/>
+                </a:solidFill>
+                <a:latin typeface="Arial"/>
+              </a:rPr>
+              <a:t> the ones it could prove and </a:t>
+            </a:r>
+            <a:r>
+              <a:rPr sz="1500" b="1" i="0">
+                <a:solidFill>
+                  <a:srgbClr val="1A1D24"/>
+                </a:solidFill>
+                <a:latin typeface="Arial"/>
+              </a:rPr>
+              <a:t>asked a human</a:t>
+            </a:r>
+            <a:r>
+              <a:rPr sz="1500" b="0" i="0">
+                <a:solidFill>
+                  <a:srgbClr val="1A1D24"/>
+                </a:solidFill>
+                <a:latin typeface="Arial"/>
+              </a:rPr>
+              <a:t> for the rest. </a:t>
+            </a:r>
+            <a:r>
+              <a:rPr sz="1500" b="1" i="0">
+                <a:solidFill>
+                  <a:srgbClr val="1A1D24"/>
+                </a:solidFill>
+                <a:latin typeface="Arial"/>
+              </a:rPr>
+              <a:t>15 / 15 correct behavior</a:t>
+            </a:r>
+            <a:r>
+              <a:rPr sz="1500" b="0" i="0">
+                <a:solidFill>
+                  <a:srgbClr val="1A1D24"/>
+                </a:solidFill>
+                <a:latin typeface="Arial"/>
+              </a:rPr>
+              <a:t> — it never bluffed.</a:t>
+            </a:r>
+          </a:p>
+        </p:txBody>
+      </p:sp>
+      <p:sp>
+        <p:nvSpPr>
+          <p:cNvPr id="9" name="TextBox 8"/>
+          <p:cNvSpPr txBox="1"/>
+          <p:nvPr/>
+        </p:nvSpPr>
+        <p:spPr>
+          <a:xfrm>
+            <a:off x="822960" y="6400800"/>
+            <a:ext cx="6400800" cy="365760"/>
           </a:xfrm>
           <a:prstGeom prst="rect">
             <a:avLst/>
@@ -5612,85 +5605,6 @@
           <a:lstStyle/>
           <a:p>
             <a:r>
-              <a:rPr sz="1400" b="1" i="0">
-                <a:solidFill>
-                  <a:srgbClr val="1A1D24"/>
-                </a:solidFill>
-                <a:latin typeface="Arial"/>
-              </a:rPr>
-              <a:t>Validated</a:t>
-            </a:r>
-            <a:r>
-              <a:rPr sz="1400" b="0" i="0">
-                <a:solidFill>
-                  <a:srgbClr val="1A1D24"/>
-                </a:solidFill>
-                <a:latin typeface="Arial"/>
-              </a:rPr>
-              <a:t> with a </a:t>
-            </a:r>
-            <a:r>
-              <a:rPr sz="1400" b="1" i="0">
-                <a:solidFill>
-                  <a:srgbClr val="1A1D24"/>
-                </a:solidFill>
-                <a:latin typeface="Arial"/>
-              </a:rPr>
-              <a:t>5 easy / 5 medium / 5 hard</a:t>
-            </a:r>
-            <a:r>
-              <a:rPr sz="1400" b="0" i="0">
-                <a:solidFill>
-                  <a:srgbClr val="1A1D24"/>
-                </a:solidFill>
-                <a:latin typeface="Arial"/>
-              </a:rPr>
-              <a:t> harness → 5/5/5, plus </a:t>
-            </a:r>
-            <a:r>
-              <a:rPr sz="1400" b="1" i="0">
-                <a:solidFill>
-                  <a:srgbClr val="1A1D24"/>
-                </a:solidFill>
-                <a:latin typeface="Arial"/>
-              </a:rPr>
-              <a:t>33 unit tests</a:t>
-            </a:r>
-            <a:r>
-              <a:rPr sz="1400" b="0" i="0">
-                <a:solidFill>
-                  <a:srgbClr val="1A1D24"/>
-                </a:solidFill>
-                <a:latin typeface="Arial"/>
-              </a:rPr>
-              <a:t> that lock the scoring.</a:t>
-            </a:r>
-          </a:p>
-        </p:txBody>
-      </p:sp>
-      <p:sp>
-        <p:nvSpPr>
-          <p:cNvPr id="8" name="TextBox 7"/>
-          <p:cNvSpPr txBox="1"/>
-          <p:nvPr/>
-        </p:nvSpPr>
-        <p:spPr>
-          <a:xfrm>
-            <a:off x="822960" y="6400800"/>
-            <a:ext cx="6400800" cy="365760"/>
-          </a:xfrm>
-          <a:prstGeom prst="rect">
-            <a:avLst/>
-          </a:prstGeom>
-          <a:noFill/>
-        </p:spPr>
-        <p:txBody>
-          <a:bodyPr wrap="square">
-            <a:spAutoFit/>
-          </a:bodyPr>
-          <a:lstStyle/>
-          <a:p>
-            <a:r>
               <a:rPr sz="1000" b="1" i="0">
                 <a:solidFill>
                   <a:srgbClr val="6B7280"/>
@@ -5704,7 +5618,7 @@
       </p:sp>
       <p:sp>
         <p:nvSpPr>
-          <p:cNvPr id="9" name="TextBox 8"/>
+          <p:cNvPr id="10" name="TextBox 9"/>
           <p:cNvSpPr txBox="1"/>
           <p:nvPr/>
         </p:nvSpPr>
@@ -5792,7 +5706,7 @@
                 </a:solidFill>
                 <a:latin typeface="Arial"/>
               </a:rPr>
-              <a:t>EVALUATION &amp; RESULTS · HARD TRUTHS</a:t>
+              <a:t>EVALUATION &amp; RESULTS</a:t>
             </a:r>
           </a:p>
         </p:txBody>
@@ -5870,7 +5784,7 @@
                 </a:solidFill>
                 <a:latin typeface="Arial"/>
               </a:rPr>
-              <a:t>What broke — and what it taught me</a:t>
+              <a:t>What I learned — the hard truths</a:t>
             </a:r>
           </a:p>
         </p:txBody>
@@ -5883,7 +5797,7 @@
         </p:nvSpPr>
         <p:spPr>
           <a:xfrm>
-            <a:off x="868680" y="1920240"/>
+            <a:off x="868680" y="2011680"/>
             <a:ext cx="10424160" cy="3931920"/>
           </a:xfrm>
           <a:prstGeom prst="rect">
@@ -5899,11 +5813,11 @@
           <a:p>
             <a:pPr>
               <a:spcAft>
-                <a:spcPts val="1200"/>
+                <a:spcPts val="1600"/>
               </a:spcAft>
             </a:pPr>
             <a:r>
-              <a:rPr sz="1500" b="1" i="0">
+              <a:rPr sz="1600" b="1" i="0">
                 <a:solidFill>
                   <a:srgbClr val="FA582D"/>
                 </a:solidFill>
@@ -5912,32 +5826,32 @@
               <a:t>●  </a:t>
             </a:r>
             <a:r>
-              <a:rPr sz="1500" b="1" i="0">
-                <a:solidFill>
-                  <a:srgbClr val="1A1D24"/>
-                </a:solidFill>
-                <a:latin typeface="Arial"/>
-              </a:rPr>
-              <a:t>Rerankers aren't calibrated.</a:t>
-            </a:r>
-            <a:r>
-              <a:rPr sz="1500" b="0" i="0">
-                <a:solidFill>
-                  <a:srgbClr val="1A1D24"/>
-                </a:solidFill>
-                <a:latin typeface="Arial"/>
-              </a:rPr>
-              <a:t> The correct passage scored lower than an off-topic one; rerankers order, the LLM judges sufficiency.</a:t>
+              <a:rPr sz="1600" b="1" i="0">
+                <a:solidFill>
+                  <a:srgbClr val="1A1D24"/>
+                </a:solidFill>
+                <a:latin typeface="Arial"/>
+              </a:rPr>
+              <a:t>Don't trust the AI's own confidence.</a:t>
+            </a:r>
+            <a:r>
+              <a:rPr sz="1600" b="0" i="0">
+                <a:solidFill>
+                  <a:srgbClr val="1A1D24"/>
+                </a:solidFill>
+                <a:latin typeface="Arial"/>
+              </a:rPr>
+              <a:t> Models sound certain even when wrong — so I have the system *calculate* confidence with rules, not ask the model.</a:t>
             </a:r>
           </a:p>
           <a:p>
             <a:pPr>
               <a:spcAft>
-                <a:spcPts val="1200"/>
+                <a:spcPts val="1600"/>
               </a:spcAft>
             </a:pPr>
             <a:r>
-              <a:rPr sz="1500" b="1" i="0">
+              <a:rPr sz="1600" b="1" i="0">
                 <a:solidFill>
                   <a:srgbClr val="FA582D"/>
                 </a:solidFill>
@@ -5946,32 +5860,32 @@
               <a:t>●  </a:t>
             </a:r>
             <a:r>
-              <a:rPr sz="1500" b="1" i="0">
-                <a:solidFill>
-                  <a:srgbClr val="1A1D24"/>
-                </a:solidFill>
-                <a:latin typeface="Arial"/>
-              </a:rPr>
-              <a:t>The newest model deprecated a setting.</a:t>
-            </a:r>
-            <a:r>
-              <a:rPr sz="1500" b="0" i="0">
-                <a:solidFill>
-                  <a:srgbClr val="1A1D24"/>
-                </a:solidFill>
-                <a:latin typeface="Arial"/>
-              </a:rPr>
-              <a:t> I set `temperature=0` for determinism → it errored → my fail-safe escalated all 15. Determinism belongs in my code.</a:t>
+              <a:rPr sz="1600" b="1" i="0">
+                <a:solidFill>
+                  <a:srgbClr val="1A1D24"/>
+                </a:solidFill>
+                <a:latin typeface="Arial"/>
+              </a:rPr>
+              <a:t>Being too careful is also a failure.</a:t>
+            </a:r>
+            <a:r>
+              <a:rPr sz="1600" b="0" i="0">
+                <a:solidFill>
+                  <a:srgbClr val="1A1D24"/>
+                </a:solidFill>
+                <a:latin typeface="Arial"/>
+              </a:rPr>
+              <a:t> Early on it sent answerable questions to a human. I tuned it to answer when it has proof — trust means answering when you can back it up, not just refusing.</a:t>
             </a:r>
           </a:p>
           <a:p>
             <a:pPr>
               <a:spcAft>
-                <a:spcPts val="1200"/>
+                <a:spcPts val="1600"/>
               </a:spcAft>
             </a:pPr>
             <a:r>
-              <a:rPr sz="1500" b="1" i="0">
+              <a:rPr sz="1600" b="1" i="0">
                 <a:solidFill>
                   <a:srgbClr val="FA582D"/>
                 </a:solidFill>
@@ -5980,56 +5894,22 @@
               <a:t>●  </a:t>
             </a:r>
             <a:r>
-              <a:rPr sz="1500" b="1" i="0">
-                <a:solidFill>
-                  <a:srgbClr val="1A1D24"/>
-                </a:solidFill>
-                <a:latin typeface="Arial"/>
-              </a:rPr>
-              <a:t>A fail-safe became bad UX.</a:t>
-            </a:r>
-            <a:r>
-              <a:rPr sz="1500" b="0" i="0">
-                <a:solidFill>
-                  <a:srgbClr val="1A1D24"/>
-                </a:solidFill>
-                <a:latin typeface="Arial"/>
-              </a:rPr>
-              <a:t> It over-escalated answerable questions; I tuned it to answer when grounded.</a:t>
-            </a:r>
-          </a:p>
-          <a:p>
-            <a:pPr>
-              <a:spcAft>
-                <a:spcPts val="1200"/>
-              </a:spcAft>
-            </a:pPr>
-            <a:r>
-              <a:rPr sz="1500" b="1" i="0">
-                <a:solidFill>
-                  <a:srgbClr val="FA582D"/>
-                </a:solidFill>
-                <a:latin typeface="Arial"/>
-              </a:rPr>
-              <a:t>●  </a:t>
-            </a:r>
-            <a:r>
-              <a:rPr sz="1500" b="1" i="0">
-                <a:solidFill>
-                  <a:srgbClr val="1A1D24"/>
-                </a:solidFill>
-                <a:latin typeface="Arial"/>
-              </a:rPr>
-              <a:t>One downvote shouldn't bury a source</a:t>
-            </a:r>
-            <a:r>
-              <a:rPr sz="1500" b="0" i="0">
-                <a:solidFill>
-                  <a:srgbClr val="1A1D24"/>
-                </a:solidFill>
-                <a:latin typeface="Arial"/>
-              </a:rPr>
-              <a:t> — added a 5-vote floor before reputation can cap (a real sparse-data bug).</a:t>
+              <a:rPr sz="1600" b="1" i="0">
+                <a:solidFill>
+                  <a:srgbClr val="1A1D24"/>
+                </a:solidFill>
+                <a:latin typeface="Arial"/>
+              </a:rPr>
+              <a:t>Small rules need real-world testing.</a:t>
+            </a:r>
+            <a:r>
+              <a:rPr sz="1600" b="0" i="0">
+                <a:solidFill>
+                  <a:srgbClr val="1A1D24"/>
+                </a:solidFill>
+                <a:latin typeface="Arial"/>
+              </a:rPr>
+              <a:t> A single “thumbs-down” could unfairly bury a good document. I only caught that by testing with real questions — and fixed it.</a:t>
             </a:r>
           </a:p>
         </p:txBody>
@@ -6249,7 +6129,7 @@
         </p:nvSpPr>
         <p:spPr>
           <a:xfrm>
-            <a:off x="868680" y="2011680"/>
+            <a:off x="868680" y="1965960"/>
             <a:ext cx="5120640" cy="3931920"/>
           </a:xfrm>
           <a:prstGeom prst="rect">
@@ -6269,7 +6149,7 @@
               </a:spcAft>
             </a:pPr>
             <a:r>
-              <a:rPr sz="1450" b="1" i="0">
+              <a:rPr sz="1400" b="1" i="0">
                 <a:solidFill>
                   <a:srgbClr val="FA582D"/>
                 </a:solidFill>
@@ -6278,13 +6158,13 @@
               <a:t>●  </a:t>
             </a:r>
             <a:r>
-              <a:rPr sz="1450" b="1" i="0">
-                <a:solidFill>
-                  <a:srgbClr val="1A1D24"/>
-                </a:solidFill>
-                <a:latin typeface="Arial"/>
-              </a:rPr>
-              <a:t>Would change:</a:t>
+              <a:rPr sz="1400" b="1" i="0">
+                <a:solidFill>
+                  <a:srgbClr val="1A1D24"/>
+                </a:solidFill>
+                <a:latin typeface="Arial"/>
+              </a:rPr>
+              <a:t>Would add / change:</a:t>
             </a:r>
           </a:p>
           <a:p>
@@ -6294,7 +6174,7 @@
               </a:spcAft>
             </a:pPr>
             <a:r>
-              <a:rPr sz="1450" b="1" i="0">
+              <a:rPr sz="1400" b="1" i="0">
                 <a:solidFill>
                   <a:srgbClr val="FA582D"/>
                 </a:solidFill>
@@ -6303,13 +6183,22 @@
               <a:t>●  </a:t>
             </a:r>
             <a:r>
-              <a:rPr sz="1450" b="0" i="0">
-                <a:solidFill>
-                  <a:srgbClr val="1A1D24"/>
-                </a:solidFill>
-                <a:latin typeface="Arial"/>
-              </a:rPr>
-              <a:t>Agentic retrieval (Corrective / Self-RAG) — critique evidence, re-search before answering.</a:t>
+              <a:rPr sz="1400" b="1" i="0">
+                <a:solidFill>
+                  <a:srgbClr val="1A1D24"/>
+                </a:solidFill>
+                <a:latin typeface="Arial"/>
+              </a:rPr>
+              <a:t>SME source certification</a:t>
+            </a:r>
+            <a:r>
+              <a:rPr sz="1400" b="0" i="0">
+                <a:solidFill>
+                  <a:srgbClr val="1A1D24"/>
+                </a:solidFill>
+                <a:latin typeface="Arial"/>
+              </a:rPr>
+              <a:t> — experts verify &amp; certify documents *before* they enter the agent, so every answer is built on accuracy-certified sources.</a:t>
             </a:r>
           </a:p>
           <a:p>
@@ -6319,7 +6208,7 @@
               </a:spcAft>
             </a:pPr>
             <a:r>
-              <a:rPr sz="1450" b="1" i="0">
+              <a:rPr sz="1400" b="1" i="0">
                 <a:solidFill>
                   <a:srgbClr val="FA582D"/>
                 </a:solidFill>
@@ -6328,13 +6217,22 @@
               <a:t>●  </a:t>
             </a:r>
             <a:r>
-              <a:rPr sz="1450" b="0" i="0">
-                <a:solidFill>
-                  <a:srgbClr val="1A1D24"/>
-                </a:solidFill>
-                <a:latin typeface="Arial"/>
-              </a:rPr>
-              <a:t>A tool-using agent for live lookups before escalating.</a:t>
+              <a:rPr sz="1400" b="1" i="0">
+                <a:solidFill>
+                  <a:srgbClr val="1A1D24"/>
+                </a:solidFill>
+                <a:latin typeface="Arial"/>
+              </a:rPr>
+              <a:t>Agentic retrieval</a:t>
+            </a:r>
+            <a:r>
+              <a:rPr sz="1400" b="0" i="0">
+                <a:solidFill>
+                  <a:srgbClr val="1A1D24"/>
+                </a:solidFill>
+                <a:latin typeface="Arial"/>
+              </a:rPr>
+              <a:t> — critique the evidence and re-search before answering; a tool-using agent for live lookups before escalating.</a:t>
             </a:r>
           </a:p>
           <a:p>
@@ -6344,7 +6242,7 @@
               </a:spcAft>
             </a:pPr>
             <a:r>
-              <a:rPr sz="1450" b="1" i="0">
+              <a:rPr sz="1400" b="1" i="0">
                 <a:solidFill>
                   <a:srgbClr val="FA582D"/>
                 </a:solidFill>
@@ -6353,33 +6251,38 @@
               <a:t>●  </a:t>
             </a:r>
             <a:r>
-              <a:rPr sz="1450" b="0" i="0">
-                <a:solidFill>
-                  <a:srgbClr val="1A1D24"/>
-                </a:solidFill>
-                <a:latin typeface="Arial"/>
-              </a:rPr>
-              <a:t>LLM-as-judge as a 2nd </a:t>
-            </a:r>
-            <a:r>
-              <a:rPr sz="1450" b="1" i="0">
-                <a:solidFill>
-                  <a:srgbClr val="1A1D24"/>
-                </a:solidFill>
-                <a:latin typeface="Arial"/>
-              </a:rPr>
-              <a:t>evaluation</a:t>
-            </a:r>
-            <a:r>
-              <a:rPr sz="1450" b="0" i="0">
-                <a:solidFill>
-                  <a:srgbClr val="1A1D24"/>
-                </a:solidFill>
-                <a:latin typeface="Arial"/>
-              </a:rPr>
-              <a:t> signal (never for user-facing confidence).</a:t>
-            </a:r>
-          </a:p>
+              <a:rPr sz="1400" b="0" i="0">
+                <a:solidFill>
+                  <a:srgbClr val="1A1D24"/>
+                </a:solidFill>
+                <a:latin typeface="Arial"/>
+              </a:rPr>
+              <a:t>Hosted embeddings + hybrid search + a feedback-tuned reranker; real Confluence/Jira connectors.</a:t>
+            </a:r>
+          </a:p>
+        </p:txBody>
+      </p:sp>
+      <p:sp>
+        <p:nvSpPr>
+          <p:cNvPr id="6" name="TextBox 5"/>
+          <p:cNvSpPr txBox="1"/>
+          <p:nvPr/>
+        </p:nvSpPr>
+        <p:spPr>
+          <a:xfrm>
+            <a:off x="6355080" y="1965960"/>
+            <a:ext cx="5029200" cy="3931920"/>
+          </a:xfrm>
+          <a:prstGeom prst="rect">
+            <a:avLst/>
+          </a:prstGeom>
+          <a:noFill/>
+        </p:spPr>
+        <p:txBody>
+          <a:bodyPr wrap="square">
+            <a:spAutoFit/>
+          </a:bodyPr>
+          <a:lstStyle/>
           <a:p>
             <a:pPr>
               <a:spcAft>
@@ -6387,7 +6290,7 @@
               </a:spcAft>
             </a:pPr>
             <a:r>
-              <a:rPr sz="1450" b="1" i="0">
+              <a:rPr sz="1400" b="1" i="0">
                 <a:solidFill>
                   <a:srgbClr val="FA582D"/>
                 </a:solidFill>
@@ -6396,38 +6299,15 @@
               <a:t>●  </a:t>
             </a:r>
             <a:r>
-              <a:rPr sz="1450" b="0" i="0">
-                <a:solidFill>
-                  <a:srgbClr val="1A1D24"/>
-                </a:solidFill>
-                <a:latin typeface="Arial"/>
-              </a:rPr>
-              <a:t>Hosted embeddings + hybrid search + a feedback-tuned reranker; real Confluence/Jira connectors.</a:t>
-            </a:r>
-          </a:p>
-        </p:txBody>
-      </p:sp>
-      <p:sp>
-        <p:nvSpPr>
-          <p:cNvPr id="6" name="TextBox 5"/>
-          <p:cNvSpPr txBox="1"/>
-          <p:nvPr/>
-        </p:nvSpPr>
-        <p:spPr>
-          <a:xfrm>
-            <a:off x="6355080" y="2011680"/>
-            <a:ext cx="5029200" cy="3931920"/>
-          </a:xfrm>
-          <a:prstGeom prst="rect">
-            <a:avLst/>
-          </a:prstGeom>
-          <a:noFill/>
-        </p:spPr>
-        <p:txBody>
-          <a:bodyPr wrap="square">
-            <a:spAutoFit/>
-          </a:bodyPr>
-          <a:lstStyle/>
+              <a:rPr sz="1400" b="1" i="0">
+                <a:solidFill>
+                  <a:srgbClr val="1A1D24"/>
+                </a:solidFill>
+                <a:latin typeface="Arial"/>
+              </a:rPr>
+              <a:t>Would NOT change — the spine:</a:t>
+            </a:r>
+          </a:p>
           <a:p>
             <a:pPr>
               <a:spcAft>
@@ -6435,7 +6315,7 @@
               </a:spcAft>
             </a:pPr>
             <a:r>
-              <a:rPr sz="1450" b="1" i="0">
+              <a:rPr sz="1400" b="1" i="0">
                 <a:solidFill>
                   <a:srgbClr val="FA582D"/>
                 </a:solidFill>
@@ -6444,13 +6324,13 @@
               <a:t>●  </a:t>
             </a:r>
             <a:r>
-              <a:rPr sz="1450" b="1" i="0">
-                <a:solidFill>
-                  <a:srgbClr val="1A1D24"/>
-                </a:solidFill>
-                <a:latin typeface="Arial"/>
-              </a:rPr>
-              <a:t>Would NOT change — the spine:</a:t>
+              <a:rPr sz="1400" b="0" i="0">
+                <a:solidFill>
+                  <a:srgbClr val="1A1D24"/>
+                </a:solidFill>
+                <a:latin typeface="Arial"/>
+              </a:rPr>
+              <a:t>Deterministic confidence.</a:t>
             </a:r>
           </a:p>
           <a:p>
@@ -6460,7 +6340,7 @@
               </a:spcAft>
             </a:pPr>
             <a:r>
-              <a:rPr sz="1450" b="1" i="0">
+              <a:rPr sz="1400" b="1" i="0">
                 <a:solidFill>
                   <a:srgbClr val="FA582D"/>
                 </a:solidFill>
@@ -6469,13 +6349,13 @@
               <a:t>●  </a:t>
             </a:r>
             <a:r>
-              <a:rPr sz="1450" b="0" i="0">
-                <a:solidFill>
-                  <a:srgbClr val="1A1D24"/>
-                </a:solidFill>
-                <a:latin typeface="Arial"/>
-              </a:rPr>
-              <a:t>Deterministic confidence.</a:t>
+              <a:rPr sz="1400" b="0" i="0">
+                <a:solidFill>
+                  <a:srgbClr val="1A1D24"/>
+                </a:solidFill>
+                <a:latin typeface="Arial"/>
+              </a:rPr>
+              <a:t>Hard citation gates.</a:t>
             </a:r>
           </a:p>
           <a:p>
@@ -6485,7 +6365,7 @@
               </a:spcAft>
             </a:pPr>
             <a:r>
-              <a:rPr sz="1450" b="1" i="0">
+              <a:rPr sz="1400" b="1" i="0">
                 <a:solidFill>
                   <a:srgbClr val="FA582D"/>
                 </a:solidFill>
@@ -6494,13 +6374,13 @@
               <a:t>●  </a:t>
             </a:r>
             <a:r>
-              <a:rPr sz="1450" b="0" i="0">
-                <a:solidFill>
-                  <a:srgbClr val="1A1D24"/>
-                </a:solidFill>
-                <a:latin typeface="Arial"/>
-              </a:rPr>
-              <a:t>Hard citation gates.</a:t>
+              <a:rPr sz="1400" b="0" i="0">
+                <a:solidFill>
+                  <a:srgbClr val="1A1D24"/>
+                </a:solidFill>
+                <a:latin typeface="Arial"/>
+              </a:rPr>
+              <a:t>The Facts ↔ Style wall.</a:t>
             </a:r>
           </a:p>
           <a:p>
@@ -6510,7 +6390,7 @@
               </a:spcAft>
             </a:pPr>
             <a:r>
-              <a:rPr sz="1450" b="1" i="0">
+              <a:rPr sz="1400" b="1" i="0">
                 <a:solidFill>
                   <a:srgbClr val="FA582D"/>
                 </a:solidFill>
@@ -6519,32 +6399,7 @@
               <a:t>●  </a:t>
             </a:r>
             <a:r>
-              <a:rPr sz="1450" b="0" i="0">
-                <a:solidFill>
-                  <a:srgbClr val="1A1D24"/>
-                </a:solidFill>
-                <a:latin typeface="Arial"/>
-              </a:rPr>
-              <a:t>The Facts ↔ Style wall.</a:t>
-            </a:r>
-          </a:p>
-          <a:p>
-            <a:pPr>
-              <a:spcAft>
-                <a:spcPts val="1100"/>
-              </a:spcAft>
-            </a:pPr>
-            <a:r>
-              <a:rPr sz="1450" b="1" i="0">
-                <a:solidFill>
-                  <a:srgbClr val="FA582D"/>
-                </a:solidFill>
-                <a:latin typeface="Arial"/>
-              </a:rPr>
-              <a:t>●  </a:t>
-            </a:r>
-            <a:r>
-              <a:rPr sz="1450" b="0" i="0">
+              <a:rPr sz="1400" b="0" i="0">
                 <a:solidFill>
                   <a:srgbClr val="1A1D24"/>
                 </a:solidFill>
@@ -8002,7 +7857,7 @@
         </p:nvSpPr>
         <p:spPr>
           <a:xfrm>
-            <a:off x="868680" y="2011680"/>
+            <a:off x="868680" y="1965960"/>
             <a:ext cx="5120640" cy="3931920"/>
           </a:xfrm>
           <a:prstGeom prst="rect">
@@ -8022,7 +7877,7 @@
               </a:spcAft>
             </a:pPr>
             <a:r>
-              <a:rPr sz="1500" b="1" i="0">
+              <a:rPr sz="1400" b="1" i="0">
                 <a:solidFill>
                   <a:srgbClr val="FA582D"/>
                 </a:solidFill>
@@ -8031,22 +7886,22 @@
               <a:t>●  </a:t>
             </a:r>
             <a:r>
-              <a:rPr sz="1500" b="1" i="0">
-                <a:solidFill>
-                  <a:srgbClr val="1A1D24"/>
-                </a:solidFill>
-                <a:latin typeface="Arial"/>
-              </a:rPr>
-              <a:t>Background:</a:t>
-            </a:r>
-            <a:r>
-              <a:rPr sz="1500" b="0" i="0">
-                <a:solidFill>
-                  <a:srgbClr val="1A1D24"/>
-                </a:solidFill>
-                <a:latin typeface="Arial"/>
-              </a:rPr>
-              <a:t> CRM / Salesforce PM — I've shipped knowledge and routing systems for sales teams.</a:t>
+              <a:rPr sz="1400" b="1" i="0">
+                <a:solidFill>
+                  <a:srgbClr val="1A1D24"/>
+                </a:solidFill>
+                <a:latin typeface="Arial"/>
+              </a:rPr>
+              <a:t>Staff Product Manager — 15+ years</a:t>
+            </a:r>
+            <a:r>
+              <a:rPr sz="1400" b="0" i="0">
+                <a:solidFill>
+                  <a:srgbClr val="1A1D24"/>
+                </a:solidFill>
+                <a:latin typeface="Arial"/>
+              </a:rPr>
+              <a:t> in enterprise CRM transformation &amp; AI-enabled workflow automation (Walmart, DoorDash, Amplitude, Gusto, Akamai).</a:t>
             </a:r>
           </a:p>
           <a:p>
@@ -8056,7 +7911,7 @@
               </a:spcAft>
             </a:pPr>
             <a:r>
-              <a:rPr sz="1500" b="1" i="0">
+              <a:rPr sz="1400" b="1" i="0">
                 <a:solidFill>
                   <a:srgbClr val="FA582D"/>
                 </a:solidFill>
@@ -8065,31 +7920,22 @@
               <a:t>●  </a:t>
             </a:r>
             <a:r>
-              <a:rPr sz="1500" b="0" i="0">
-                <a:solidFill>
-                  <a:srgbClr val="1A1D24"/>
-                </a:solidFill>
-                <a:latin typeface="Arial"/>
-              </a:rPr>
-              <a:t>This product is those patterns rebuilt for AI: </a:t>
-            </a:r>
-            <a:r>
-              <a:rPr sz="1500" b="1" i="0">
-                <a:solidFill>
-                  <a:srgbClr val="1A1D24"/>
-                </a:solidFill>
-                <a:latin typeface="Arial"/>
-              </a:rPr>
-              <a:t>Knowledge articles, Omni-Channel routing, approval flows, scoring</a:t>
-            </a:r>
-            <a:r>
-              <a:rPr sz="1500" b="0" i="0">
-                <a:solidFill>
-                  <a:srgbClr val="1A1D24"/>
-                </a:solidFill>
-                <a:latin typeface="Arial"/>
-              </a:rPr>
-              <a:t> — now grounded in an LLM.</a:t>
+              <a:rPr sz="1400" b="1" i="0">
+                <a:solidFill>
+                  <a:srgbClr val="1A1D24"/>
+                </a:solidFill>
+                <a:latin typeface="Arial"/>
+              </a:rPr>
+              <a:t>Applied AI track record:</a:t>
+            </a:r>
+            <a:r>
+              <a:rPr sz="1400" b="0" i="0">
+                <a:solidFill>
+                  <a:srgbClr val="1A1D24"/>
+                </a:solidFill>
+                <a:latin typeface="Arial"/>
+              </a:rPr>
+              <a:t> a GenAI content platform with LLM orchestration; Salesforce Agentforce (intelligent routing, case deflection, AI summaries); predictive account scoring with Data Science.</a:t>
             </a:r>
           </a:p>
           <a:p>
@@ -8099,7 +7945,7 @@
               </a:spcAft>
             </a:pPr>
             <a:r>
-              <a:rPr sz="1500" b="1" i="0">
+              <a:rPr sz="1400" b="1" i="0">
                 <a:solidFill>
                   <a:srgbClr val="FA582D"/>
                 </a:solidFill>
@@ -8108,13 +7954,31 @@
               <a:t>●  </a:t>
             </a:r>
             <a:r>
-              <a:rPr sz="1500" b="0" i="0">
-                <a:solidFill>
-                  <a:srgbClr val="1A1D24"/>
-                </a:solidFill>
-                <a:latin typeface="Arial"/>
-              </a:rPr>
-              <a:t>New to the AI stack; I learned it by building this end-to-end.</a:t>
+              <a:rPr sz="1400" b="0" i="0">
+                <a:solidFill>
+                  <a:srgbClr val="1A1D24"/>
+                </a:solidFill>
+                <a:latin typeface="Arial"/>
+              </a:rPr>
+              <a:t>This product is my world rebuilt on an LLM — </a:t>
+            </a:r>
+            <a:r>
+              <a:rPr sz="1400" b="1" i="0">
+                <a:solidFill>
+                  <a:srgbClr val="1A1D24"/>
+                </a:solidFill>
+                <a:latin typeface="Arial"/>
+              </a:rPr>
+              <a:t>knowledge, routing, approvals, and scoring</a:t>
+            </a:r>
+            <a:r>
+              <a:rPr sz="1400" b="0" i="0">
+                <a:solidFill>
+                  <a:srgbClr val="1A1D24"/>
+                </a:solidFill>
+                <a:latin typeface="Arial"/>
+              </a:rPr>
+              <a:t>, grounded and governed.</a:t>
             </a:r>
           </a:p>
         </p:txBody>
@@ -8127,7 +7991,7 @@
         </p:nvSpPr>
         <p:spPr>
           <a:xfrm>
-            <a:off x="6355080" y="2011680"/>
+            <a:off x="6355080" y="1965960"/>
             <a:ext cx="5029200" cy="3931920"/>
           </a:xfrm>
           <a:prstGeom prst="rect">
@@ -8147,7 +8011,7 @@
               </a:spcAft>
             </a:pPr>
             <a:r>
-              <a:rPr sz="1500" b="1" i="0">
+              <a:rPr sz="1400" b="1" i="0">
                 <a:solidFill>
                   <a:srgbClr val="FA582D"/>
                 </a:solidFill>
@@ -8156,7 +8020,7 @@
               <a:t>●  </a:t>
             </a:r>
             <a:r>
-              <a:rPr sz="1500" b="1" i="0">
+              <a:rPr sz="1400" b="1" i="0">
                 <a:solidFill>
                   <a:srgbClr val="1A1D24"/>
                 </a:solidFill>
@@ -8172,7 +8036,7 @@
               </a:spcAft>
             </a:pPr>
             <a:r>
-              <a:rPr sz="1500" b="1" i="0">
+              <a:rPr sz="1400" b="1" i="0">
                 <a:solidFill>
                   <a:srgbClr val="FA582D"/>
                 </a:solidFill>
@@ -8181,7 +8045,7 @@
               <a:t>●  </a:t>
             </a:r>
             <a:r>
-              <a:rPr sz="1500" b="1" i="0">
+              <a:rPr sz="1400" b="1" i="0">
                 <a:solidFill>
                   <a:srgbClr val="1A1D24"/>
                 </a:solidFill>
@@ -8190,7 +8054,7 @@
               <a:t>Slice the risk</a:t>
             </a:r>
             <a:r>
-              <a:rPr sz="1500" b="0" i="0">
+              <a:rPr sz="1400" b="0" i="0">
                 <a:solidFill>
                   <a:srgbClr val="1A1D24"/>
                 </a:solidFill>
@@ -8206,7 +8070,7 @@
               </a:spcAft>
             </a:pPr>
             <a:r>
-              <a:rPr sz="1500" b="1" i="0">
+              <a:rPr sz="1400" b="1" i="0">
                 <a:solidFill>
                   <a:srgbClr val="FA582D"/>
                 </a:solidFill>
@@ -8215,7 +8079,7 @@
               <a:t>●  </a:t>
             </a:r>
             <a:r>
-              <a:rPr sz="1500" b="1" i="0">
+              <a:rPr sz="1400" b="1" i="0">
                 <a:solidFill>
                   <a:srgbClr val="1A1D24"/>
                 </a:solidFill>
@@ -8224,7 +8088,7 @@
               <a:t>Determinism where trust lives</a:t>
             </a:r>
             <a:r>
-              <a:rPr sz="1500" b="0" i="0">
+              <a:rPr sz="1400" b="0" i="0">
                 <a:solidFill>
                   <a:srgbClr val="1A1D24"/>
                 </a:solidFill>
@@ -8240,7 +8104,7 @@
               </a:spcAft>
             </a:pPr>
             <a:r>
-              <a:rPr sz="1500" b="1" i="0">
+              <a:rPr sz="1400" b="1" i="0">
                 <a:solidFill>
                   <a:srgbClr val="FA582D"/>
                 </a:solidFill>
@@ -8249,7 +8113,7 @@
               <a:t>●  </a:t>
             </a:r>
             <a:r>
-              <a:rPr sz="1500" b="1" i="0">
+              <a:rPr sz="1400" b="1" i="0">
                 <a:solidFill>
                   <a:srgbClr val="1A1D24"/>
                 </a:solidFill>
@@ -8258,7 +8122,7 @@
               <a:t>Make trust legible</a:t>
             </a:r>
             <a:r>
-              <a:rPr sz="1500" b="0" i="0">
+              <a:rPr sz="1400" b="0" i="0">
                 <a:solidFill>
                   <a:srgbClr val="1A1D24"/>
                 </a:solidFill>
@@ -8776,7 +8640,7 @@
                 </a:solidFill>
                 <a:latin typeface="Arial"/>
               </a:rPr>
-              <a:t>The task, and the user pain it solves</a:t>
+              <a:t>The need, and the user pain it solves</a:t>
             </a:r>
           </a:p>
         </p:txBody>
@@ -8833,7 +8697,7 @@
                 </a:solidFill>
                 <a:latin typeface="Arial"/>
               </a:rPr>
-              <a:t> Technical Sales / Sales Engineers, answering product questions </a:t>
+              <a:t> Technical Sales team members who need answers about a </a:t>
             </a:r>
             <a:r>
               <a:rPr sz="1500" b="1" i="0">
@@ -8842,7 +8706,16 @@
                 </a:solidFill>
                 <a:latin typeface="Arial"/>
               </a:rPr>
-              <a:t>live in a customer call.</a:t>
+              <a:t>specific Palo Alto product</a:t>
+            </a:r>
+            <a:r>
+              <a:rPr sz="1500" b="0" i="0">
+                <a:solidFill>
+                  <a:srgbClr val="1A1D24"/>
+                </a:solidFill>
+                <a:latin typeface="Arial"/>
+              </a:rPr>
+              <a:t>.</a:t>
             </a:r>
           </a:p>
           <a:p>
@@ -8867,7 +8740,7 @@
                 </a:solidFill>
                 <a:latin typeface="Arial"/>
               </a:rPr>
-              <a:t>The pain:</a:t>
+              <a:t>The need:</a:t>
             </a:r>
             <a:r>
               <a:rPr sz="1500" b="0" i="0">
@@ -8876,7 +8749,25 @@
                 </a:solidFill>
                 <a:latin typeface="Arial"/>
               </a:rPr>
-              <a:t> a confident-but-wrong answer loses credibility and the deal.</a:t>
+              <a:t> a system where they can ask a product question and get a </a:t>
+            </a:r>
+            <a:r>
+              <a:rPr sz="1500" b="1" i="0">
+                <a:solidFill>
+                  <a:srgbClr val="1A1D24"/>
+                </a:solidFill>
+                <a:latin typeface="Arial"/>
+              </a:rPr>
+              <a:t>trustworthy, sourced</a:t>
+            </a:r>
+            <a:r>
+              <a:rPr sz="1500" b="0" i="0">
+                <a:solidFill>
+                  <a:srgbClr val="1A1D24"/>
+                </a:solidFill>
+                <a:latin typeface="Arial"/>
+              </a:rPr>
+              <a:t> answer.</a:t>
             </a:r>
           </a:p>
           <a:p>
@@ -8895,13 +8786,40 @@
               <a:t>●  </a:t>
             </a:r>
             <a:r>
+              <a:rPr sz="1500" b="1" i="0">
+                <a:solidFill>
+                  <a:srgbClr val="1A1D24"/>
+                </a:solidFill>
+                <a:latin typeface="Arial"/>
+              </a:rPr>
+              <a:t>The pain:</a:t>
+            </a:r>
+            <a:r>
               <a:rPr sz="1500" b="0" i="0">
                 <a:solidFill>
                   <a:srgbClr val="1A1D24"/>
                 </a:solidFill>
                 <a:latin typeface="Arial"/>
               </a:rPr>
-              <a:t>Product truth is scattered across docs, release notes, and wikis — and it </a:t>
+              <a:t> product truth is </a:t>
+            </a:r>
+            <a:r>
+              <a:rPr sz="1500" b="1" i="0">
+                <a:solidFill>
+                  <a:srgbClr val="1A1D24"/>
+                </a:solidFill>
+                <a:latin typeface="Arial"/>
+              </a:rPr>
+              <a:t>scattered</a:t>
+            </a:r>
+            <a:r>
+              <a:rPr sz="1500" b="0" i="0">
+                <a:solidFill>
+                  <a:srgbClr val="1A1D24"/>
+                </a:solidFill>
+                <a:latin typeface="Arial"/>
+              </a:rPr>
+              <a:t> across docs, release notes, and wikis — and it </a:t>
             </a:r>
             <a:r>
               <a:rPr sz="1500" b="1" i="0">
@@ -8944,7 +8862,7 @@
                 </a:solidFill>
                 <a:latin typeface="Arial"/>
               </a:rPr>
-              <a:t>Experts re-answer the same questions in Slack; that knowledge is never reused.</a:t>
+              <a:t>Experts re-answer the same questions; that knowledge is never captured or reused.</a:t>
             </a:r>
           </a:p>
         </p:txBody>
@@ -9094,7 +9012,7 @@
                 </a:solidFill>
                 <a:latin typeface="Arial"/>
               </a:rPr>
-              <a:t>_Analogy: give a rep the official binder and say 'only quote from this, cite the page.'_</a:t>
+              <a:t>_Analogy: give the team the official binder and say 'only quote from this, cite the page.'_</a:t>
             </a:r>
           </a:p>
         </p:txBody>

</xml_diff>

<commit_message>
Deck: Option-A philosophy wording, italic rendering fix, sample tests on eval slide
- Slide 4: clearer "Technical-PM philosophy" wording (tackle the scariest risk first /
  let the AI write, let code decide / show your work).
- rich(): render _italic_ markers properly (were showing as literal underscores).
- Slide 13 (Evaluation & Results): added metric chips + a table of three real sample
  test questions with color-coded results (Easy=High, Medium=capped, Hard=escalated).

Co-Authored-By: Claude Opus 4.8 <noreply@anthropic.com>
</commit_message>
<xml_diff>
--- a/presentation/Executive_Presentation.pptx
+++ b/presentation/Executive_Presentation.pptx
@@ -5164,8 +5164,8 @@
         </p:nvSpPr>
         <p:spPr>
           <a:xfrm>
-            <a:off x="868680" y="1737360"/>
-            <a:ext cx="10424160" cy="3931920"/>
+            <a:off x="868680" y="1645920"/>
+            <a:ext cx="10424160" cy="365760"/>
           </a:xfrm>
           <a:prstGeom prst="rect">
             <a:avLst/>
@@ -5178,20 +5178,6 @@
           </a:bodyPr>
           <a:lstStyle/>
           <a:p>
-            <a:pPr>
-              <a:spcAft>
-                <a:spcPts val="600"/>
-              </a:spcAft>
-            </a:pPr>
-            <a:r>
-              <a:rPr sz="1500" b="1" i="0">
-                <a:solidFill>
-                  <a:srgbClr val="FA582D"/>
-                </a:solidFill>
-                <a:latin typeface="Arial"/>
-              </a:rPr>
-              <a:t>●  </a:t>
-            </a:r>
             <a:r>
               <a:rPr sz="1500" b="0" i="0">
                 <a:solidFill>
@@ -5199,22 +5185,335 @@
                 </a:solidFill>
                 <a:latin typeface="Arial"/>
               </a:rPr>
-              <a:t>Not “does it sound smart?” — I set quality bars a salesperson can rely on:</a:t>
+              <a:t>I set quality bars a salesperson can rely on — then validated with real questions:</a:t>
+            </a:r>
+          </a:p>
+        </p:txBody>
+      </p:sp>
+      <p:sp>
+        <p:nvSpPr>
+          <p:cNvPr id="6" name="Rounded Rectangle 5"/>
+          <p:cNvSpPr/>
+          <p:nvPr/>
+        </p:nvSpPr>
+        <p:spPr>
+          <a:xfrm>
+            <a:off x="868680" y="2121408"/>
+            <a:ext cx="3383280" cy="914400"/>
+          </a:xfrm>
+          <a:prstGeom prst="roundRect">
+            <a:avLst/>
+          </a:prstGeom>
+          <a:solidFill>
+            <a:srgbClr val="E7F4EC"/>
+          </a:solidFill>
+          <a:ln w="12700">
+            <a:solidFill>
+              <a:srgbClr val="1E8E3E"/>
+            </a:solidFill>
+          </a:ln>
+          <a:effectLst/>
+        </p:spPr>
+        <p:style>
+          <a:lnRef idx="1">
+            <a:schemeClr val="accent1"/>
+          </a:lnRef>
+          <a:fillRef idx="3">
+            <a:schemeClr val="accent1"/>
+          </a:fillRef>
+          <a:effectRef idx="2">
+            <a:schemeClr val="accent1"/>
+          </a:effectRef>
+          <a:fontRef idx="minor">
+            <a:schemeClr val="lt1"/>
+          </a:fontRef>
+        </p:style>
+        <p:txBody>
+          <a:bodyPr rtlCol="0" anchor="ctr"/>
+          <a:lstStyle/>
+          <a:p>
+            <a:pPr algn="ctr"/>
+          </a:p>
+        </p:txBody>
+      </p:sp>
+      <p:sp>
+        <p:nvSpPr>
+          <p:cNvPr id="7" name="TextBox 6"/>
+          <p:cNvSpPr txBox="1"/>
+          <p:nvPr/>
+        </p:nvSpPr>
+        <p:spPr>
+          <a:xfrm>
+            <a:off x="868680" y="2212848"/>
+            <a:ext cx="3383280" cy="777240"/>
+          </a:xfrm>
+          <a:prstGeom prst="rect">
+            <a:avLst/>
+          </a:prstGeom>
+          <a:noFill/>
+        </p:spPr>
+        <p:txBody>
+          <a:bodyPr wrap="square">
+            <a:spAutoFit/>
+          </a:bodyPr>
+          <a:lstStyle/>
+          <a:p>
+            <a:pPr algn="ctr"/>
+            <a:r>
+              <a:rPr sz="2600" b="1" i="0">
+                <a:solidFill>
+                  <a:srgbClr val="1E8E3E"/>
+                </a:solidFill>
+                <a:latin typeface="Arial"/>
+              </a:rPr>
+              <a:t>100%</a:t>
+            </a:r>
+          </a:p>
+          <a:p>
+            <a:pPr algn="ctr"/>
+            <a:r>
+              <a:rPr sz="1200" b="0" i="0">
+                <a:solidFill>
+                  <a:srgbClr val="1A1D24"/>
+                </a:solidFill>
+                <a:latin typeface="Arial"/>
+              </a:rPr>
+              <a:t>every answer shows its source</a:t>
+            </a:r>
+          </a:p>
+        </p:txBody>
+      </p:sp>
+      <p:sp>
+        <p:nvSpPr>
+          <p:cNvPr id="8" name="Rounded Rectangle 7"/>
+          <p:cNvSpPr/>
+          <p:nvPr/>
+        </p:nvSpPr>
+        <p:spPr>
+          <a:xfrm>
+            <a:off x="4416552" y="2121408"/>
+            <a:ext cx="3383280" cy="914400"/>
+          </a:xfrm>
+          <a:prstGeom prst="roundRect">
+            <a:avLst/>
+          </a:prstGeom>
+          <a:solidFill>
+            <a:srgbClr val="E7F4EC"/>
+          </a:solidFill>
+          <a:ln w="12700">
+            <a:solidFill>
+              <a:srgbClr val="1E8E3E"/>
+            </a:solidFill>
+          </a:ln>
+          <a:effectLst/>
+        </p:spPr>
+        <p:style>
+          <a:lnRef idx="1">
+            <a:schemeClr val="accent1"/>
+          </a:lnRef>
+          <a:fillRef idx="3">
+            <a:schemeClr val="accent1"/>
+          </a:fillRef>
+          <a:effectRef idx="2">
+            <a:schemeClr val="accent1"/>
+          </a:effectRef>
+          <a:fontRef idx="minor">
+            <a:schemeClr val="lt1"/>
+          </a:fontRef>
+        </p:style>
+        <p:txBody>
+          <a:bodyPr rtlCol="0" anchor="ctr"/>
+          <a:lstStyle/>
+          <a:p>
+            <a:pPr algn="ctr"/>
+          </a:p>
+        </p:txBody>
+      </p:sp>
+      <p:sp>
+        <p:nvSpPr>
+          <p:cNvPr id="9" name="TextBox 8"/>
+          <p:cNvSpPr txBox="1"/>
+          <p:nvPr/>
+        </p:nvSpPr>
+        <p:spPr>
+          <a:xfrm>
+            <a:off x="4416552" y="2212848"/>
+            <a:ext cx="3383280" cy="777240"/>
+          </a:xfrm>
+          <a:prstGeom prst="rect">
+            <a:avLst/>
+          </a:prstGeom>
+          <a:noFill/>
+        </p:spPr>
+        <p:txBody>
+          <a:bodyPr wrap="square">
+            <a:spAutoFit/>
+          </a:bodyPr>
+          <a:lstStyle/>
+          <a:p>
+            <a:pPr algn="ctr"/>
+            <a:r>
+              <a:rPr sz="2600" b="1" i="0">
+                <a:solidFill>
+                  <a:srgbClr val="1E8E3E"/>
+                </a:solidFill>
+                <a:latin typeface="Arial"/>
+              </a:rPr>
+              <a:t>0%</a:t>
+            </a:r>
+          </a:p>
+          <a:p>
+            <a:pPr algn="ctr"/>
+            <a:r>
+              <a:rPr sz="1200" b="0" i="0">
+                <a:solidFill>
+                  <a:srgbClr val="1A1D24"/>
+                </a:solidFill>
+                <a:latin typeface="Arial"/>
+              </a:rPr>
+              <a:t>from outdated / retired documents</a:t>
+            </a:r>
+          </a:p>
+        </p:txBody>
+      </p:sp>
+      <p:sp>
+        <p:nvSpPr>
+          <p:cNvPr id="10" name="Rounded Rectangle 9"/>
+          <p:cNvSpPr/>
+          <p:nvPr/>
+        </p:nvSpPr>
+        <p:spPr>
+          <a:xfrm>
+            <a:off x="7964424" y="2121408"/>
+            <a:ext cx="3383280" cy="914400"/>
+          </a:xfrm>
+          <a:prstGeom prst="roundRect">
+            <a:avLst/>
+          </a:prstGeom>
+          <a:solidFill>
+            <a:srgbClr val="E7F4EC"/>
+          </a:solidFill>
+          <a:ln w="12700">
+            <a:solidFill>
+              <a:srgbClr val="1E8E3E"/>
+            </a:solidFill>
+          </a:ln>
+          <a:effectLst/>
+        </p:spPr>
+        <p:style>
+          <a:lnRef idx="1">
+            <a:schemeClr val="accent1"/>
+          </a:lnRef>
+          <a:fillRef idx="3">
+            <a:schemeClr val="accent1"/>
+          </a:fillRef>
+          <a:effectRef idx="2">
+            <a:schemeClr val="accent1"/>
+          </a:effectRef>
+          <a:fontRef idx="minor">
+            <a:schemeClr val="lt1"/>
+          </a:fontRef>
+        </p:style>
+        <p:txBody>
+          <a:bodyPr rtlCol="0" anchor="ctr"/>
+          <a:lstStyle/>
+          <a:p>
+            <a:pPr algn="ctr"/>
+          </a:p>
+        </p:txBody>
+      </p:sp>
+      <p:sp>
+        <p:nvSpPr>
+          <p:cNvPr id="11" name="TextBox 10"/>
+          <p:cNvSpPr txBox="1"/>
+          <p:nvPr/>
+        </p:nvSpPr>
+        <p:spPr>
+          <a:xfrm>
+            <a:off x="7964424" y="2212848"/>
+            <a:ext cx="3383280" cy="777240"/>
+          </a:xfrm>
+          <a:prstGeom prst="rect">
+            <a:avLst/>
+          </a:prstGeom>
+          <a:noFill/>
+        </p:spPr>
+        <p:txBody>
+          <a:bodyPr wrap="square">
+            <a:spAutoFit/>
+          </a:bodyPr>
+          <a:lstStyle/>
+          <a:p>
+            <a:pPr algn="ctr"/>
+            <a:r>
+              <a:rPr sz="2600" b="1" i="0">
+                <a:solidFill>
+                  <a:srgbClr val="1E8E3E"/>
+                </a:solidFill>
+                <a:latin typeface="Arial"/>
+              </a:rPr>
+              <a:t>0%</a:t>
+            </a:r>
+          </a:p>
+          <a:p>
+            <a:pPr algn="ctr"/>
+            <a:r>
+              <a:rPr sz="1200" b="0" i="0">
+                <a:solidFill>
+                  <a:srgbClr val="1A1D24"/>
+                </a:solidFill>
+                <a:latin typeface="Arial"/>
+              </a:rPr>
+              <a:t>shaky answers shown as solid</a:t>
+            </a:r>
+          </a:p>
+        </p:txBody>
+      </p:sp>
+      <p:sp>
+        <p:nvSpPr>
+          <p:cNvPr id="12" name="TextBox 11"/>
+          <p:cNvSpPr txBox="1"/>
+          <p:nvPr/>
+        </p:nvSpPr>
+        <p:spPr>
+          <a:xfrm>
+            <a:off x="868680" y="3246120"/>
+            <a:ext cx="10424160" cy="365760"/>
+          </a:xfrm>
+          <a:prstGeom prst="rect">
+            <a:avLst/>
+          </a:prstGeom>
+          <a:noFill/>
+        </p:spPr>
+        <p:txBody>
+          <a:bodyPr wrap="square">
+            <a:spAutoFit/>
+          </a:bodyPr>
+          <a:lstStyle/>
+          <a:p>
+            <a:r>
+              <a:rPr sz="1400" b="1" i="0">
+                <a:solidFill>
+                  <a:srgbClr val="1A1D24"/>
+                </a:solidFill>
+                <a:latin typeface="Arial"/>
+              </a:rPr>
+              <a:t>Validated with 15 real questions — 5 easy · 5 medium · 5 hard. A few examples:</a:t>
             </a:r>
           </a:p>
         </p:txBody>
       </p:sp>
       <p:graphicFrame>
         <p:nvGraphicFramePr>
-          <p:cNvPr id="6" name="Table 5"/>
+          <p:cNvPr id="13" name="Table 12"/>
           <p:cNvGraphicFramePr>
             <a:graphicFrameLocks noGrp="1"/>
           </p:cNvGraphicFramePr>
           <p:nvPr/>
         </p:nvGraphicFramePr>
         <p:xfrm>
-          <a:off x="868680" y="2286000"/>
-          <a:ext cx="10424160" cy="1609344"/>
+          <a:off x="868680" y="3657600"/>
+          <a:ext cx="10424160" cy="1554480"/>
         </p:xfrm>
         <a:graphic>
           <a:graphicData uri="http://schemas.openxmlformats.org/drawingml/2006/table">
@@ -5223,23 +5522,24 @@
                 <a:tableStyleId>{5C22544A-7EE6-4342-B048-85BDC9FD1C3A}</a:tableStyleId>
               </a:tblPr>
               <a:tblGrid>
-                <a:gridCol w="7680960"/>
-                <a:gridCol w="2743200"/>
+                <a:gridCol w="5852160"/>
+                <a:gridCol w="1463040"/>
+                <a:gridCol w="3108960"/>
               </a:tblGrid>
-              <a:tr h="402336">
+              <a:tr h="388620">
                 <a:tc>
                   <a:txBody>
                     <a:bodyPr/>
                     <a:lstStyle/>
                     <a:p>
                       <a:r>
-                        <a:rPr sz="1400" b="1" i="0">
+                        <a:rPr sz="1250" b="1" i="0">
                           <a:solidFill>
                             <a:srgbClr val="FFFFFF"/>
                           </a:solidFill>
                           <a:latin typeface="Arial"/>
                         </a:rPr>
-                        <a:t>What I measured</a:t>
+                        <a:t>Sample question</a:t>
                       </a:r>
                     </a:p>
                   </a:txBody>
@@ -5255,13 +5555,35 @@
                     <a:lstStyle/>
                     <a:p>
                       <a:r>
-                        <a:rPr sz="1400" b="1" i="0">
+                        <a:rPr sz="1250" b="1" i="0">
                           <a:solidFill>
                             <a:srgbClr val="FFFFFF"/>
                           </a:solidFill>
                           <a:latin typeface="Arial"/>
                         </a:rPr>
-                        <a:t>Target</a:t>
+                        <a:t>Difficulty</a:t>
+                      </a:r>
+                    </a:p>
+                  </a:txBody>
+                  <a:tcPr>
+                    <a:solidFill>
+                      <a:srgbClr val="1A1D24"/>
+                    </a:solidFill>
+                  </a:tcPr>
+                </a:tc>
+                <a:tc>
+                  <a:txBody>
+                    <a:bodyPr/>
+                    <a:lstStyle/>
+                    <a:p>
+                      <a:r>
+                        <a:rPr sz="1250" b="1" i="0">
+                          <a:solidFill>
+                            <a:srgbClr val="FFFFFF"/>
+                          </a:solidFill>
+                          <a:latin typeface="Arial"/>
+                        </a:rPr>
+                        <a:t>Result</a:t>
                       </a:r>
                     </a:p>
                   </a:txBody>
@@ -5272,20 +5594,20 @@
                   </a:tcPr>
                 </a:tc>
               </a:tr>
-              <a:tr h="402336">
+              <a:tr h="388620">
                 <a:tc>
                   <a:txBody>
                     <a:bodyPr/>
                     <a:lstStyle/>
                     <a:p>
                       <a:r>
-                        <a:rPr sz="1400" b="0" i="0">
+                        <a:rPr sz="1200" b="0" i="0">
                           <a:solidFill>
-                            <a:srgbClr val="E0410F"/>
+                            <a:srgbClr val="1A1D24"/>
                           </a:solidFill>
                           <a:latin typeface="Arial"/>
                         </a:rPr>
-                        <a:t>Every answer shows its source</a:t>
+                        <a:t>“What is the max number of BGP IP addresses per remote network?”</a:t>
                       </a:r>
                     </a:p>
                   </a:txBody>
@@ -5301,13 +5623,35 @@
                     <a:lstStyle/>
                     <a:p>
                       <a:r>
-                        <a:rPr sz="1400" b="0" i="0">
+                        <a:rPr sz="1200" b="1" i="0">
                           <a:solidFill>
                             <a:srgbClr val="1A1D24"/>
                           </a:solidFill>
                           <a:latin typeface="Arial"/>
                         </a:rPr>
-                        <a:t>100%</a:t>
+                        <a:t>Easy</a:t>
+                      </a:r>
+                    </a:p>
+                  </a:txBody>
+                  <a:tcPr>
+                    <a:solidFill>
+                      <a:srgbClr val="FFFFFF"/>
+                    </a:solidFill>
+                  </a:tcPr>
+                </a:tc>
+                <a:tc>
+                  <a:txBody>
+                    <a:bodyPr/>
+                    <a:lstStyle/>
+                    <a:p>
+                      <a:r>
+                        <a:rPr sz="1200" b="1" i="0">
+                          <a:solidFill>
+                            <a:srgbClr val="1E8E3E"/>
+                          </a:solidFill>
+                          <a:latin typeface="Arial"/>
+                        </a:rPr>
+                        <a:t>High · answered + cited</a:t>
                       </a:r>
                     </a:p>
                   </a:txBody>
@@ -5318,20 +5662,20 @@
                   </a:tcPr>
                 </a:tc>
               </a:tr>
-              <a:tr h="402336">
+              <a:tr h="388620">
                 <a:tc>
                   <a:txBody>
                     <a:bodyPr/>
                     <a:lstStyle/>
                     <a:p>
                       <a:r>
-                        <a:rPr sz="1400" b="0" i="0">
+                        <a:rPr sz="1200" b="0" i="0">
                           <a:solidFill>
-                            <a:srgbClr val="E0410F"/>
+                            <a:srgbClr val="1A1D24"/>
                           </a:solidFill>
                           <a:latin typeface="Arial"/>
                         </a:rPr>
-                        <a:t>Answers drawn from outdated / retired documents</a:t>
+                        <a:t>“What are the decryption types on the NGFW?”</a:t>
                       </a:r>
                     </a:p>
                   </a:txBody>
@@ -5347,13 +5691,35 @@
                     <a:lstStyle/>
                     <a:p>
                       <a:r>
-                        <a:rPr sz="1400" b="0" i="0">
+                        <a:rPr sz="1200" b="1" i="0">
                           <a:solidFill>
                             <a:srgbClr val="1A1D24"/>
                           </a:solidFill>
                           <a:latin typeface="Arial"/>
                         </a:rPr>
-                        <a:t>0%</a:t>
+                        <a:t>Medium</a:t>
+                      </a:r>
+                    </a:p>
+                  </a:txBody>
+                  <a:tcPr>
+                    <a:solidFill>
+                      <a:srgbClr val="F6F7F9"/>
+                    </a:solidFill>
+                  </a:tcPr>
+                </a:tc>
+                <a:tc>
+                  <a:txBody>
+                    <a:bodyPr/>
+                    <a:lstStyle/>
+                    <a:p>
+                      <a:r>
+                        <a:rPr sz="1200" b="1" i="0">
+                          <a:solidFill>
+                            <a:srgbClr val="C77700"/>
+                          </a:solidFill>
+                          <a:latin typeface="Arial"/>
+                        </a:rPr>
+                        <a:t>Medium · source is 241 days old</a:t>
                       </a:r>
                     </a:p>
                   </a:txBody>
@@ -5364,20 +5730,20 @@
                   </a:tcPr>
                 </a:tc>
               </a:tr>
-              <a:tr h="402336">
+              <a:tr h="388620">
                 <a:tc>
                   <a:txBody>
                     <a:bodyPr/>
                     <a:lstStyle/>
                     <a:p>
                       <a:r>
-                        <a:rPr sz="1400" b="0" i="0">
+                        <a:rPr sz="1200" b="0" i="0">
                           <a:solidFill>
-                            <a:srgbClr val="E0410F"/>
+                            <a:srgbClr val="1A1D24"/>
                           </a:solidFill>
                           <a:latin typeface="Arial"/>
                         </a:rPr>
-                        <a:t>A shaky answer shown as if it were solid</a:t>
+                        <a:t>“What is the per-user price of Prisma Access?”</a:t>
                       </a:r>
                     </a:p>
                   </a:txBody>
@@ -5393,13 +5759,35 @@
                     <a:lstStyle/>
                     <a:p>
                       <a:r>
-                        <a:rPr sz="1400" b="0" i="0">
+                        <a:rPr sz="1200" b="1" i="0">
                           <a:solidFill>
                             <a:srgbClr val="1A1D24"/>
                           </a:solidFill>
                           <a:latin typeface="Arial"/>
                         </a:rPr>
-                        <a:t>0%  (it asks a human instead)</a:t>
+                        <a:t>Hard</a:t>
+                      </a:r>
+                    </a:p>
+                  </a:txBody>
+                  <a:tcPr>
+                    <a:solidFill>
+                      <a:srgbClr val="FFFFFF"/>
+                    </a:solidFill>
+                  </a:tcPr>
+                </a:tc>
+                <a:tc>
+                  <a:txBody>
+                    <a:bodyPr/>
+                    <a:lstStyle/>
+                    <a:p>
+                      <a:r>
+                        <a:rPr sz="1200" b="1" i="0">
+                          <a:solidFill>
+                            <a:srgbClr val="D6312B"/>
+                          </a:solidFill>
+                          <a:latin typeface="Arial"/>
+                        </a:rPr>
+                        <a:t>Escalated to an SME</a:t>
                       </a:r>
                     </a:p>
                   </a:txBody>
@@ -5416,14 +5804,14 @@
       </p:graphicFrame>
       <p:sp>
         <p:nvSpPr>
-          <p:cNvPr id="7" name="Rounded Rectangle 6"/>
+          <p:cNvPr id="14" name="Rounded Rectangle 13"/>
           <p:cNvSpPr/>
           <p:nvPr/>
         </p:nvSpPr>
         <p:spPr>
           <a:xfrm>
-            <a:off x="868680" y="4160520"/>
-            <a:ext cx="10424160" cy="1463040"/>
+            <a:off x="868680" y="5394960"/>
+            <a:ext cx="10424160" cy="841248"/>
           </a:xfrm>
           <a:prstGeom prst="roundRect">
             <a:avLst/>
@@ -5462,14 +5850,14 @@
       </p:sp>
       <p:sp>
         <p:nvSpPr>
-          <p:cNvPr id="8" name="TextBox 7"/>
+          <p:cNvPr id="15" name="TextBox 14"/>
           <p:cNvSpPr txBox="1"/>
           <p:nvPr/>
         </p:nvSpPr>
         <p:spPr>
           <a:xfrm>
-            <a:off x="1143000" y="4297680"/>
-            <a:ext cx="9966960" cy="1234440"/>
+            <a:off x="1143000" y="5477256"/>
+            <a:ext cx="9966960" cy="676656"/>
           </a:xfrm>
           <a:prstGeom prst="rect">
             <a:avLst/>
@@ -5485,85 +5873,6 @@
             <a:r>
               <a:rPr sz="1400" b="1" i="0">
                 <a:solidFill>
-                  <a:srgbClr val="1E8E3E"/>
-                </a:solidFill>
-                <a:latin typeface="Arial"/>
-              </a:rPr>
-              <a:t>How I validated it</a:t>
-            </a:r>
-          </a:p>
-          <a:p>
-            <a:pPr>
-              <a:spcBef>
-                <a:spcPts val="500"/>
-              </a:spcBef>
-            </a:pPr>
-            <a:r>
-              <a:rPr sz="1500" b="0" i="0">
-                <a:solidFill>
-                  <a:srgbClr val="1A1D24"/>
-                </a:solidFill>
-                <a:latin typeface="Arial"/>
-              </a:rPr>
-              <a:t>I tested </a:t>
-            </a:r>
-            <a:r>
-              <a:rPr sz="1500" b="1" i="0">
-                <a:solidFill>
-                  <a:srgbClr val="1A1D24"/>
-                </a:solidFill>
-                <a:latin typeface="Arial"/>
-              </a:rPr>
-              <a:t>15 real questions</a:t>
-            </a:r>
-            <a:r>
-              <a:rPr sz="1500" b="0" i="0">
-                <a:solidFill>
-                  <a:srgbClr val="1A1D24"/>
-                </a:solidFill>
-                <a:latin typeface="Arial"/>
-              </a:rPr>
-              <a:t> — 5 easy, 5 medium, 5 hard. It </a:t>
-            </a:r>
-            <a:r>
-              <a:rPr sz="1500" b="1" i="0">
-                <a:solidFill>
-                  <a:srgbClr val="1A1D24"/>
-                </a:solidFill>
-                <a:latin typeface="Arial"/>
-              </a:rPr>
-              <a:t>answered</a:t>
-            </a:r>
-            <a:r>
-              <a:rPr sz="1500" b="0" i="0">
-                <a:solidFill>
-                  <a:srgbClr val="1A1D24"/>
-                </a:solidFill>
-                <a:latin typeface="Arial"/>
-              </a:rPr>
-              <a:t> the ones it could prove and </a:t>
-            </a:r>
-            <a:r>
-              <a:rPr sz="1500" b="1" i="0">
-                <a:solidFill>
-                  <a:srgbClr val="1A1D24"/>
-                </a:solidFill>
-                <a:latin typeface="Arial"/>
-              </a:rPr>
-              <a:t>asked a human</a:t>
-            </a:r>
-            <a:r>
-              <a:rPr sz="1500" b="0" i="0">
-                <a:solidFill>
-                  <a:srgbClr val="1A1D24"/>
-                </a:solidFill>
-                <a:latin typeface="Arial"/>
-              </a:rPr>
-              <a:t> for the rest. </a:t>
-            </a:r>
-            <a:r>
-              <a:rPr sz="1500" b="1" i="0">
-                <a:solidFill>
                   <a:srgbClr val="1A1D24"/>
                 </a:solidFill>
                 <a:latin typeface="Arial"/>
@@ -5571,20 +5880,20 @@
               <a:t>15 / 15 correct behavior</a:t>
             </a:r>
             <a:r>
-              <a:rPr sz="1500" b="0" i="0">
-                <a:solidFill>
-                  <a:srgbClr val="1A1D24"/>
-                </a:solidFill>
-                <a:latin typeface="Arial"/>
-              </a:rPr>
-              <a:t> — it never bluffed.</a:t>
-            </a:r>
-          </a:p>
-        </p:txBody>
-      </p:sp>
-      <p:sp>
-        <p:nvSpPr>
-          <p:cNvPr id="9" name="TextBox 8"/>
+              <a:rPr sz="1400" b="0" i="0">
+                <a:solidFill>
+                  <a:srgbClr val="1A1D24"/>
+                </a:solidFill>
+                <a:latin typeface="Arial"/>
+              </a:rPr>
+              <a:t> — it answered what it could prove, and asked a human for the rest. It never bluffed.</a:t>
+            </a:r>
+          </a:p>
+        </p:txBody>
+      </p:sp>
+      <p:sp>
+        <p:nvSpPr>
+          <p:cNvPr id="16" name="TextBox 15"/>
           <p:cNvSpPr txBox="1"/>
           <p:nvPr/>
         </p:nvSpPr>
@@ -5618,7 +5927,7 @@
       </p:sp>
       <p:sp>
         <p:nvSpPr>
-          <p:cNvPr id="10" name="TextBox 9"/>
+          <p:cNvPr id="17" name="TextBox 16"/>
           <p:cNvSpPr txBox="1"/>
           <p:nvPr/>
         </p:nvSpPr>
@@ -6399,13 +6708,13 @@
               <a:t>●  </a:t>
             </a:r>
             <a:r>
-              <a:rPr sz="1400" b="0" i="0">
-                <a:solidFill>
-                  <a:srgbClr val="1A1D24"/>
-                </a:solidFill>
-                <a:latin typeface="Arial"/>
-              </a:rPr>
-              <a:t>_These earned the trust; everything else is an optimization._</a:t>
+              <a:rPr sz="1400" b="0" i="1">
+                <a:solidFill>
+                  <a:srgbClr val="1A1D24"/>
+                </a:solidFill>
+                <a:latin typeface="Arial"/>
+              </a:rPr>
+              <a:t>These earned the trust; everything else is an optimization.</a:t>
             </a:r>
           </a:p>
         </p:txBody>
@@ -8051,7 +8360,7 @@
                 </a:solidFill>
                 <a:latin typeface="Arial"/>
               </a:rPr>
-              <a:t>Slice the risk</a:t>
+              <a:t>Tackle the scariest risk first.</a:t>
             </a:r>
             <a:r>
               <a:rPr sz="1400" b="0" i="0">
@@ -8060,7 +8369,7 @@
                 </a:solidFill>
                 <a:latin typeface="Arial"/>
               </a:rPr>
-              <a:t> — ship the thinnest vertical that retires the riskiest assumption first (here: *trust*).</a:t>
+              <a:t> I built the full trust loop (cited answer → confidence → escalation) before any polish — the real risk was trust, not “can AI answer.”</a:t>
             </a:r>
           </a:p>
           <a:p>
@@ -8085,7 +8394,7 @@
                 </a:solidFill>
                 <a:latin typeface="Arial"/>
               </a:rPr>
-              <a:t>Determinism where trust lives</a:t>
+              <a:t>Let the AI write; let code decide.</a:t>
             </a:r>
             <a:r>
               <a:rPr sz="1400" b="0" i="0">
@@ -8094,7 +8403,7 @@
                 </a:solidFill>
                 <a:latin typeface="Arial"/>
               </a:rPr>
-              <a:t> — the LLM drafts language; code makes the trust decisions.</a:t>
+              <a:t> The AI drafts the wording; rules decide what's cited and how confident we are — predictable and auditable.</a:t>
             </a:r>
           </a:p>
           <a:p>
@@ -8119,7 +8428,7 @@
                 </a:solidFill>
                 <a:latin typeface="Arial"/>
               </a:rPr>
-              <a:t>Make trust legible</a:t>
+              <a:t>Show your work.</a:t>
             </a:r>
             <a:r>
               <a:rPr sz="1400" b="0" i="0">
@@ -8128,7 +8437,7 @@
                 </a:solidFill>
                 <a:latin typeface="Arial"/>
               </a:rPr>
-              <a:t> — every score is explained; every claim shows its source.</a:t>
+              <a:t> Never just “Medium” — explain why, and show the exact source so the user can verify.</a:t>
             </a:r>
           </a:p>
         </p:txBody>
@@ -9006,13 +9315,13 @@
               <a:t>●  </a:t>
             </a:r>
             <a:r>
-              <a:rPr sz="1500" b="0" i="0">
-                <a:solidFill>
-                  <a:srgbClr val="1A1D24"/>
-                </a:solidFill>
-                <a:latin typeface="Arial"/>
-              </a:rPr>
-              <a:t>_Analogy: give the team the official binder and say 'only quote from this, cite the page.'_</a:t>
+              <a:rPr sz="1500" b="0" i="1">
+                <a:solidFill>
+                  <a:srgbClr val="1A1D24"/>
+                </a:solidFill>
+                <a:latin typeface="Arial"/>
+              </a:rPr>
+              <a:t>Analogy: give the team the official binder and say 'only quote from this, cite the page.'</a:t>
             </a:r>
           </a:p>
         </p:txBody>

</xml_diff>